<commit_message>
Fill founder details on Team slide from resume
Replace the founder-bio DRAFT placeholder on slide 11 with real
credentials: PwC audit, multi-entity close at The Siegfried Group,
B.S. Accounting (FIU), GAAP/AICPA, QuickBooks/SAP/Oracle, Excel Expert.
Headcount CONFIRM placeholder retained pending confirmation.

Co-Authored-By: Claude Opus 4.8 <noreply@anthropic.com>
Claude-Session: https://claude.ai/code/session_01QtqbMjEmhryZUuczZogog1
</commit_message>
<xml_diff>
--- a/outputs/aicpa-accelerator-pitch-deck.pptx
+++ b/outputs/aicpa-accelerator-pitch-deck.pptx
@@ -3477,18 +3477,399 @@
       </p:sp>
       <p:sp>
         <p:nvSpPr>
-          <p:cNvPr id="12" name="Shape 7"/>
+          <p:cNvPr id="12" name="Text 7"/>
+          <p:cNvSpPr txBox="1"/>
+          <p:nvPr/>
+        </p:nvSpPr>
+        <p:spPr>
+          <a:xfrm>
+            <a:off x="877824" y="3182112"/>
+            <a:ext cx="4677156" cy="960120"/>
+          </a:xfrm>
+          <a:prstGeom prst="rect">
+            <a:avLst/>
+          </a:prstGeom>
+          <a:noFill/>
+          <a:ln/>
+        </p:spPr>
+        <p:txBody>
+          <a:bodyPr wrap="square" lIns="0" tIns="0" rIns="0" bIns="0" rtlCol="0" anchor="ctr"/>
+          <a:lstStyle/>
+          <a:p>
+            <a:pPr algn="l" indent="0" marL="0">
+              <a:lnSpc>
+                <a:spcPct val="106000"/>
+              </a:lnSpc>
+              <a:buNone/>
+            </a:pPr>
+            <a:r>
+              <a:rPr lang="en-US" sz="1250" dirty="0">
+                <a:solidFill>
+                  <a:srgbClr val="CBD5E1"/>
+                </a:solidFill>
+                <a:latin typeface="Nunito" pitchFamily="34" charset="0"/>
+                <a:ea typeface="Nunito" pitchFamily="34" charset="-122"/>
+                <a:cs typeface="Nunito" pitchFamily="34" charset="-120"/>
+              </a:rPr>
+              <a:t>Eight plus years in accounting. Audit at </a:t>
+            </a:r>
+            <a:pPr algn="l" indent="0" marL="0">
+              <a:lnSpc>
+                <a:spcPct val="106000"/>
+              </a:lnSpc>
+              <a:buNone/>
+            </a:pPr>
+            <a:r>
+              <a:rPr lang="en-US" sz="1250" b="1" dirty="0">
+                <a:solidFill>
+                  <a:srgbClr val="FFFFFF"/>
+                </a:solidFill>
+                <a:latin typeface="Nunito" pitchFamily="34" charset="0"/>
+                <a:ea typeface="Nunito" pitchFamily="34" charset="-122"/>
+                <a:cs typeface="Nunito" pitchFamily="34" charset="-120"/>
+              </a:rPr>
+              <a:t>PricewaterhouseCoopers</a:t>
+            </a:r>
+            <a:pPr algn="l" indent="0" marL="0">
+              <a:lnSpc>
+                <a:spcPct val="106000"/>
+              </a:lnSpc>
+              <a:buNone/>
+            </a:pPr>
+            <a:r>
+              <a:rPr lang="en-US" sz="1250" dirty="0">
+                <a:solidFill>
+                  <a:srgbClr val="CBD5E1"/>
+                </a:solidFill>
+                <a:latin typeface="Nunito" pitchFamily="34" charset="0"/>
+                <a:ea typeface="Nunito" pitchFamily="34" charset="-122"/>
+                <a:cs typeface="Nunito" pitchFamily="34" charset="-120"/>
+              </a:rPr>
+              <a:t>, then multi-entity month-end close, accruals, and balance sheet reconciliations at </a:t>
+            </a:r>
+            <a:pPr algn="l" indent="0" marL="0">
+              <a:lnSpc>
+                <a:spcPct val="106000"/>
+              </a:lnSpc>
+              <a:buNone/>
+            </a:pPr>
+            <a:r>
+              <a:rPr lang="en-US" sz="1250" b="1" dirty="0">
+                <a:solidFill>
+                  <a:srgbClr val="FFFFFF"/>
+                </a:solidFill>
+                <a:latin typeface="Nunito" pitchFamily="34" charset="0"/>
+                <a:ea typeface="Nunito" pitchFamily="34" charset="-122"/>
+                <a:cs typeface="Nunito" pitchFamily="34" charset="-120"/>
+              </a:rPr>
+              <a:t>The Siegfried Group</a:t>
+            </a:r>
+            <a:pPr algn="l" indent="0" marL="0">
+              <a:lnSpc>
+                <a:spcPct val="106000"/>
+              </a:lnSpc>
+              <a:buNone/>
+            </a:pPr>
+            <a:r>
+              <a:rPr lang="en-US" sz="1250" dirty="0">
+                <a:solidFill>
+                  <a:srgbClr val="CBD5E1"/>
+                </a:solidFill>
+                <a:latin typeface="Nunito" pitchFamily="34" charset="0"/>
+                <a:ea typeface="Nunito" pitchFamily="34" charset="-122"/>
+                <a:cs typeface="Nunito" pitchFamily="34" charset="-120"/>
+              </a:rPr>
+              <a:t>. The work LunarLogic builds systems for is work Jonathan has done by hand.</a:t>
+            </a:r>
+            <a:endParaRPr lang="en-US" sz="1250" dirty="0"/>
+          </a:p>
+        </p:txBody>
+      </p:sp>
+      <p:sp>
+        <p:nvSpPr>
+          <p:cNvPr id="13" name="Text 8"/>
+          <p:cNvSpPr txBox="1"/>
+          <p:nvPr/>
+        </p:nvSpPr>
+        <p:spPr>
+          <a:xfrm>
+            <a:off x="877824" y="4206240"/>
+            <a:ext cx="4677156" cy="237744"/>
+          </a:xfrm>
+          <a:prstGeom prst="rect">
+            <a:avLst/>
+          </a:prstGeom>
+          <a:noFill/>
+          <a:ln/>
+        </p:spPr>
+        <p:txBody>
+          <a:bodyPr wrap="square" lIns="0" tIns="0" rIns="0" bIns="0" rtlCol="0" anchor="ctr"/>
+          <a:lstStyle/>
+          <a:p>
+            <a:pPr indent="0" marL="0">
+              <a:buNone/>
+            </a:pPr>
+            <a:r>
+              <a:rPr lang="en-US" sz="1050" b="1" spc="100" kern="0" dirty="0">
+                <a:solidFill>
+                  <a:srgbClr val="60A5FA"/>
+                </a:solidFill>
+                <a:latin typeface="Nunito" pitchFamily="34" charset="0"/>
+                <a:ea typeface="Nunito" pitchFamily="34" charset="-122"/>
+                <a:cs typeface="Nunito" pitchFamily="34" charset="-120"/>
+              </a:rPr>
+              <a:t>CREDENTIALS</a:t>
+            </a:r>
+            <a:endParaRPr lang="en-US" sz="1050" dirty="0"/>
+          </a:p>
+        </p:txBody>
+      </p:sp>
+      <p:sp>
+        <p:nvSpPr>
+          <p:cNvPr id="14" name="Text 9"/>
+          <p:cNvSpPr txBox="1"/>
+          <p:nvPr/>
+        </p:nvSpPr>
+        <p:spPr>
+          <a:xfrm>
+            <a:off x="877824" y="4462272"/>
+            <a:ext cx="4677156" cy="548640"/>
+          </a:xfrm>
+          <a:prstGeom prst="rect">
+            <a:avLst/>
+          </a:prstGeom>
+          <a:noFill/>
+          <a:ln/>
+        </p:spPr>
+        <p:txBody>
+          <a:bodyPr wrap="square" lIns="0" tIns="0" rIns="0" bIns="0" rtlCol="0" anchor="ctr"/>
+          <a:lstStyle/>
+          <a:p>
+            <a:pPr algn="l" indent="0" marL="0">
+              <a:lnSpc>
+                <a:spcPct val="105000"/>
+              </a:lnSpc>
+              <a:buNone/>
+            </a:pPr>
+            <a:r>
+              <a:rPr lang="en-US" sz="1150" dirty="0">
+                <a:solidFill>
+                  <a:srgbClr val="94A3B8"/>
+                </a:solidFill>
+                <a:latin typeface="Nunito" pitchFamily="34" charset="0"/>
+                <a:ea typeface="Nunito" pitchFamily="34" charset="-122"/>
+                <a:cs typeface="Nunito" pitchFamily="34" charset="-120"/>
+              </a:rPr>
+              <a:t>B.S. Accounting, Florida International University   ·   GAAP and AICPA standards   ·   QuickBooks, SAP, Oracle   ·   Excel Expert Certified</a:t>
+            </a:r>
+            <a:endParaRPr lang="en-US" sz="1150" dirty="0"/>
+          </a:p>
+        </p:txBody>
+      </p:sp>
+      <p:sp>
+        <p:nvSpPr>
+          <p:cNvPr id="15" name="Shape 10"/>
           <p:cNvSpPr/>
           <p:nvPr/>
         </p:nvSpPr>
         <p:spPr>
           <a:xfrm>
-            <a:off x="877824" y="3291840"/>
-            <a:ext cx="4677156" cy="1508760"/>
+            <a:off x="6323076" y="2011680"/>
+            <a:ext cx="5298948" cy="3063240"/>
           </a:xfrm>
           <a:prstGeom prst="roundRect">
             <a:avLst>
-              <a:gd name="adj" fmla="val 3636"/>
+              <a:gd name="adj" fmla="val 2985"/>
+            </a:avLst>
+          </a:prstGeom>
+          <a:solidFill>
+            <a:srgbClr val="1E293B">
+              <a:alpha val="55000"/>
+            </a:srgbClr>
+          </a:solidFill>
+          <a:ln w="12700">
+            <a:solidFill>
+              <a:srgbClr val="334155"/>
+            </a:solidFill>
+            <a:prstDash val="solid"/>
+          </a:ln>
+        </p:spPr>
+      </p:sp>
+      <p:pic>
+        <p:nvPicPr>
+          <p:cNvPr id="16" name="Image 3" descr="preencoded.png">    </p:cNvPr>
+          <p:cNvPicPr>
+            <a:picLocks noChangeAspect="1"/>
+          </p:cNvPicPr>
+          <p:nvPr/>
+        </p:nvPicPr>
+        <p:blipFill>
+          <a:blip r:embed="rId4"/>
+          <a:stretch>
+            <a:fillRect/>
+          </a:stretch>
+        </p:blipFill>
+        <p:spPr>
+          <a:xfrm>
+            <a:off x="6633972" y="2322576"/>
+            <a:ext cx="658368" cy="658368"/>
+          </a:xfrm>
+          <a:prstGeom prst="rect">
+            <a:avLst/>
+          </a:prstGeom>
+        </p:spPr>
+      </p:pic>
+      <p:sp>
+        <p:nvSpPr>
+          <p:cNvPr id="17" name="Text 11"/>
+          <p:cNvSpPr txBox="1"/>
+          <p:nvPr/>
+        </p:nvSpPr>
+        <p:spPr>
+          <a:xfrm>
+            <a:off x="7456932" y="2340864"/>
+            <a:ext cx="3927348" cy="329184"/>
+          </a:xfrm>
+          <a:prstGeom prst="rect">
+            <a:avLst/>
+          </a:prstGeom>
+          <a:noFill/>
+          <a:ln/>
+        </p:spPr>
+        <p:txBody>
+          <a:bodyPr wrap="square" lIns="0" tIns="0" rIns="0" bIns="0" rtlCol="0" anchor="ctr"/>
+          <a:lstStyle/>
+          <a:p>
+            <a:pPr algn="l" indent="0" marL="0">
+              <a:buNone/>
+            </a:pPr>
+            <a:r>
+              <a:rPr lang="en-US" sz="1700" b="1" dirty="0">
+                <a:solidFill>
+                  <a:srgbClr val="FFFFFF"/>
+                </a:solidFill>
+                <a:latin typeface="Nunito" pitchFamily="34" charset="0"/>
+                <a:ea typeface="Nunito" pitchFamily="34" charset="-122"/>
+                <a:cs typeface="Nunito" pitchFamily="34" charset="-120"/>
+              </a:rPr>
+              <a:t>Chris Elmore</a:t>
+            </a:r>
+            <a:endParaRPr lang="en-US" sz="1700" dirty="0"/>
+          </a:p>
+        </p:txBody>
+      </p:sp>
+      <p:sp>
+        <p:nvSpPr>
+          <p:cNvPr id="18" name="Text 12"/>
+          <p:cNvSpPr txBox="1"/>
+          <p:nvPr/>
+        </p:nvSpPr>
+        <p:spPr>
+          <a:xfrm>
+            <a:off x="7456932" y="2688336"/>
+            <a:ext cx="3927348" cy="274320"/>
+          </a:xfrm>
+          <a:prstGeom prst="rect">
+            <a:avLst/>
+          </a:prstGeom>
+          <a:noFill/>
+          <a:ln/>
+        </p:spPr>
+        <p:txBody>
+          <a:bodyPr wrap="square" lIns="0" tIns="0" rIns="0" bIns="0" rtlCol="0" anchor="ctr"/>
+          <a:lstStyle/>
+          <a:p>
+            <a:pPr algn="l" indent="0" marL="0">
+              <a:buNone/>
+            </a:pPr>
+            <a:r>
+              <a:rPr lang="en-US" sz="1300" dirty="0">
+                <a:solidFill>
+                  <a:srgbClr val="60A5FA"/>
+                </a:solidFill>
+                <a:latin typeface="Nunito" pitchFamily="34" charset="0"/>
+                <a:ea typeface="Nunito" pitchFamily="34" charset="-122"/>
+                <a:cs typeface="Nunito" pitchFamily="34" charset="-120"/>
+              </a:rPr>
+              <a:t>Advisor, pitch and go to market</a:t>
+            </a:r>
+            <a:endParaRPr lang="en-US" sz="1300" dirty="0"/>
+          </a:p>
+        </p:txBody>
+      </p:sp>
+      <p:sp>
+        <p:nvSpPr>
+          <p:cNvPr id="19" name="Text 13"/>
+          <p:cNvSpPr txBox="1"/>
+          <p:nvPr/>
+        </p:nvSpPr>
+        <p:spPr>
+          <a:xfrm>
+            <a:off x="6633972" y="3246120"/>
+            <a:ext cx="4677156" cy="1645920"/>
+          </a:xfrm>
+          <a:prstGeom prst="rect">
+            <a:avLst/>
+          </a:prstGeom>
+          <a:noFill/>
+          <a:ln/>
+        </p:spPr>
+        <p:txBody>
+          <a:bodyPr wrap="square" lIns="0" tIns="0" rIns="0" bIns="0" rtlCol="0" anchor="ctr"/>
+          <a:lstStyle/>
+          <a:p>
+            <a:pPr algn="l" indent="0" marL="0">
+              <a:lnSpc>
+                <a:spcPct val="106000"/>
+              </a:lnSpc>
+              <a:buNone/>
+            </a:pPr>
+            <a:r>
+              <a:rPr lang="en-US" sz="1250" dirty="0">
+                <a:solidFill>
+                  <a:srgbClr val="CBD5E1"/>
+                </a:solidFill>
+                <a:latin typeface="Nunito" pitchFamily="34" charset="0"/>
+                <a:ea typeface="Nunito" pitchFamily="34" charset="-122"/>
+                <a:cs typeface="Nunito" pitchFamily="34" charset="-120"/>
+              </a:rPr>
+              <a:t>First employee at AvidXchange in 2000, through its October 2021 NASDAQ IPO (AVDX), now one of the largest accounts payable automation platforms in the country. </a:t>
+            </a:r>
+            <a:pPr algn="l" indent="0" marL="0">
+              <a:lnSpc>
+                <a:spcPct val="106000"/>
+              </a:lnSpc>
+              <a:buNone/>
+            </a:pPr>
+            <a:r>
+              <a:rPr lang="en-US" sz="1250" dirty="0">
+                <a:solidFill>
+                  <a:srgbClr val="94A3B8"/>
+                </a:solidFill>
+                <a:latin typeface="Nunito" pitchFamily="34" charset="0"/>
+                <a:ea typeface="Nunito" pitchFamily="34" charset="-122"/>
+                <a:cs typeface="Nunito" pitchFamily="34" charset="-120"/>
+              </a:rPr>
+              <a:t>Also adjunct professor of entrepreneurship at UNC Charlotte and Queens University of Charlotte.</a:t>
+            </a:r>
+            <a:endParaRPr lang="en-US" sz="1250" dirty="0"/>
+          </a:p>
+        </p:txBody>
+      </p:sp>
+      <p:sp>
+        <p:nvSpPr>
+          <p:cNvPr id="20" name="Shape 14"/>
+          <p:cNvSpPr/>
+          <p:nvPr/>
+        </p:nvSpPr>
+        <p:spPr>
+          <a:xfrm>
+            <a:off x="566928" y="5257800"/>
+            <a:ext cx="11055096" cy="658368"/>
+          </a:xfrm>
+          <a:prstGeom prst="roundRect">
+            <a:avLst>
+              <a:gd name="adj" fmla="val 8333"/>
             </a:avLst>
           </a:prstGeom>
           <a:solidFill>
@@ -3506,13 +3887,13 @@
       </p:sp>
       <p:sp>
         <p:nvSpPr>
-          <p:cNvPr id="13" name="Shape 8"/>
+          <p:cNvPr id="21" name="Shape 15"/>
           <p:cNvSpPr/>
           <p:nvPr/>
         </p:nvSpPr>
         <p:spPr>
           <a:xfrm>
-            <a:off x="1005840" y="3410712"/>
+            <a:off x="694944" y="5376672"/>
             <a:ext cx="713232" cy="237744"/>
           </a:xfrm>
           <a:prstGeom prst="roundRect">
@@ -3528,305 +3909,8 @@
       </p:sp>
       <p:sp>
         <p:nvSpPr>
-          <p:cNvPr id="14" name="Text 9"/>
-          <p:cNvSpPr txBox="1"/>
-          <p:nvPr/>
-        </p:nvSpPr>
-        <p:spPr>
-          <a:xfrm>
-            <a:off x="1005840" y="3410712"/>
-            <a:ext cx="713232" cy="237744"/>
-          </a:xfrm>
-          <a:prstGeom prst="rect">
-            <a:avLst/>
-          </a:prstGeom>
-          <a:noFill/>
-          <a:ln/>
-        </p:spPr>
-        <p:txBody>
-          <a:bodyPr wrap="square" lIns="0" tIns="0" rIns="0" bIns="0" rtlCol="0" anchor="ctr"/>
-          <a:lstStyle/>
-          <a:p>
-            <a:pPr algn="ctr" indent="0" marL="0">
-              <a:buNone/>
-            </a:pPr>
-            <a:r>
-              <a:rPr lang="en-US" sz="1000" b="1" spc="100" kern="0" dirty="0">
-                <a:solidFill>
-                  <a:srgbClr val="3B2E00"/>
-                </a:solidFill>
-                <a:latin typeface="Nunito" pitchFamily="34" charset="0"/>
-                <a:ea typeface="Nunito" pitchFamily="34" charset="-122"/>
-                <a:cs typeface="Nunito" pitchFamily="34" charset="-120"/>
-              </a:rPr>
-              <a:t>DRAFT</a:t>
-            </a:r>
-            <a:endParaRPr lang="en-US" sz="1000" dirty="0"/>
-          </a:p>
-        </p:txBody>
-      </p:sp>
-      <p:sp>
-        <p:nvSpPr>
-          <p:cNvPr id="15" name="Text 10"/>
-          <p:cNvSpPr txBox="1"/>
-          <p:nvPr/>
-        </p:nvSpPr>
-        <p:spPr>
-          <a:xfrm>
-            <a:off x="1828800" y="3364992"/>
-            <a:ext cx="3579876" cy="1362456"/>
-          </a:xfrm>
-          <a:prstGeom prst="rect">
-            <a:avLst/>
-          </a:prstGeom>
-          <a:noFill/>
-          <a:ln/>
-        </p:spPr>
-        <p:txBody>
-          <a:bodyPr wrap="square" lIns="0" tIns="0" rIns="0" bIns="0" rtlCol="0" anchor="ctr"/>
-          <a:lstStyle/>
-          <a:p>
-            <a:pPr algn="l" indent="0" marL="0">
-              <a:buNone/>
-            </a:pPr>
-            <a:r>
-              <a:rPr lang="en-US" sz="1150" i="1" dirty="0">
-                <a:solidFill>
-                  <a:srgbClr val="FBBF24"/>
-                </a:solidFill>
-                <a:latin typeface="Nunito" pitchFamily="34" charset="0"/>
-                <a:ea typeface="Nunito" pitchFamily="34" charset="-122"/>
-                <a:cs typeface="Nunito" pitchFamily="34" charset="-120"/>
-              </a:rPr>
-              <a:t>CONFIRM: prior consulting firm name and years, plus any direct accounting or finance credentials or technical background, before finalizing this slide.</a:t>
-            </a:r>
-            <a:endParaRPr lang="en-US" sz="1150" dirty="0"/>
-          </a:p>
-        </p:txBody>
-      </p:sp>
-      <p:sp>
-        <p:nvSpPr>
-          <p:cNvPr id="16" name="Shape 11"/>
-          <p:cNvSpPr/>
-          <p:nvPr/>
-        </p:nvSpPr>
-        <p:spPr>
-          <a:xfrm>
-            <a:off x="6323076" y="2011680"/>
-            <a:ext cx="5298948" cy="3063240"/>
-          </a:xfrm>
-          <a:prstGeom prst="roundRect">
-            <a:avLst>
-              <a:gd name="adj" fmla="val 2985"/>
-            </a:avLst>
-          </a:prstGeom>
-          <a:solidFill>
-            <a:srgbClr val="1E293B">
-              <a:alpha val="55000"/>
-            </a:srgbClr>
-          </a:solidFill>
-          <a:ln w="12700">
-            <a:solidFill>
-              <a:srgbClr val="334155"/>
-            </a:solidFill>
-            <a:prstDash val="solid"/>
-          </a:ln>
-        </p:spPr>
-      </p:sp>
-      <p:pic>
-        <p:nvPicPr>
-          <p:cNvPr id="17" name="Image 3" descr="preencoded.png">    </p:cNvPr>
-          <p:cNvPicPr>
-            <a:picLocks noChangeAspect="1"/>
-          </p:cNvPicPr>
-          <p:nvPr/>
-        </p:nvPicPr>
-        <p:blipFill>
-          <a:blip r:embed="rId4"/>
-          <a:stretch>
-            <a:fillRect/>
-          </a:stretch>
-        </p:blipFill>
-        <p:spPr>
-          <a:xfrm>
-            <a:off x="6633972" y="2322576"/>
-            <a:ext cx="658368" cy="658368"/>
-          </a:xfrm>
-          <a:prstGeom prst="rect">
-            <a:avLst/>
-          </a:prstGeom>
-        </p:spPr>
-      </p:pic>
-      <p:sp>
-        <p:nvSpPr>
-          <p:cNvPr id="18" name="Text 12"/>
-          <p:cNvSpPr txBox="1"/>
-          <p:nvPr/>
-        </p:nvSpPr>
-        <p:spPr>
-          <a:xfrm>
-            <a:off x="7456932" y="2340864"/>
-            <a:ext cx="3927348" cy="329184"/>
-          </a:xfrm>
-          <a:prstGeom prst="rect">
-            <a:avLst/>
-          </a:prstGeom>
-          <a:noFill/>
-          <a:ln/>
-        </p:spPr>
-        <p:txBody>
-          <a:bodyPr wrap="square" lIns="0" tIns="0" rIns="0" bIns="0" rtlCol="0" anchor="ctr"/>
-          <a:lstStyle/>
-          <a:p>
-            <a:pPr algn="l" indent="0" marL="0">
-              <a:buNone/>
-            </a:pPr>
-            <a:r>
-              <a:rPr lang="en-US" sz="1700" b="1" dirty="0">
-                <a:solidFill>
-                  <a:srgbClr val="FFFFFF"/>
-                </a:solidFill>
-                <a:latin typeface="Nunito" pitchFamily="34" charset="0"/>
-                <a:ea typeface="Nunito" pitchFamily="34" charset="-122"/>
-                <a:cs typeface="Nunito" pitchFamily="34" charset="-120"/>
-              </a:rPr>
-              <a:t>Chris Elmore</a:t>
-            </a:r>
-            <a:endParaRPr lang="en-US" sz="1700" dirty="0"/>
-          </a:p>
-        </p:txBody>
-      </p:sp>
-      <p:sp>
-        <p:nvSpPr>
-          <p:cNvPr id="19" name="Text 13"/>
-          <p:cNvSpPr txBox="1"/>
-          <p:nvPr/>
-        </p:nvSpPr>
-        <p:spPr>
-          <a:xfrm>
-            <a:off x="7456932" y="2688336"/>
-            <a:ext cx="3927348" cy="274320"/>
-          </a:xfrm>
-          <a:prstGeom prst="rect">
-            <a:avLst/>
-          </a:prstGeom>
-          <a:noFill/>
-          <a:ln/>
-        </p:spPr>
-        <p:txBody>
-          <a:bodyPr wrap="square" lIns="0" tIns="0" rIns="0" bIns="0" rtlCol="0" anchor="ctr"/>
-          <a:lstStyle/>
-          <a:p>
-            <a:pPr algn="l" indent="0" marL="0">
-              <a:buNone/>
-            </a:pPr>
-            <a:r>
-              <a:rPr lang="en-US" sz="1300" dirty="0">
-                <a:solidFill>
-                  <a:srgbClr val="60A5FA"/>
-                </a:solidFill>
-                <a:latin typeface="Nunito" pitchFamily="34" charset="0"/>
-                <a:ea typeface="Nunito" pitchFamily="34" charset="-122"/>
-                <a:cs typeface="Nunito" pitchFamily="34" charset="-120"/>
-              </a:rPr>
-              <a:t>Advisor, pitch and go to market</a:t>
-            </a:r>
-            <a:endParaRPr lang="en-US" sz="1300" dirty="0"/>
-          </a:p>
-        </p:txBody>
-      </p:sp>
-      <p:sp>
-        <p:nvSpPr>
-          <p:cNvPr id="20" name="Text 14"/>
-          <p:cNvSpPr txBox="1"/>
-          <p:nvPr/>
-        </p:nvSpPr>
-        <p:spPr>
-          <a:xfrm>
-            <a:off x="6633972" y="3246120"/>
-            <a:ext cx="4677156" cy="1645920"/>
-          </a:xfrm>
-          <a:prstGeom prst="rect">
-            <a:avLst/>
-          </a:prstGeom>
-          <a:noFill/>
-          <a:ln/>
-        </p:spPr>
-        <p:txBody>
-          <a:bodyPr wrap="square" lIns="0" tIns="0" rIns="0" bIns="0" rtlCol="0" anchor="ctr"/>
-          <a:lstStyle/>
-          <a:p>
-            <a:pPr algn="l" indent="0" marL="0">
-              <a:lnSpc>
-                <a:spcPct val="106000"/>
-              </a:lnSpc>
-              <a:buNone/>
-            </a:pPr>
-            <a:r>
-              <a:rPr lang="en-US" sz="1250" dirty="0">
-                <a:solidFill>
-                  <a:srgbClr val="CBD5E1"/>
-                </a:solidFill>
-                <a:latin typeface="Nunito" pitchFamily="34" charset="0"/>
-                <a:ea typeface="Nunito" pitchFamily="34" charset="-122"/>
-                <a:cs typeface="Nunito" pitchFamily="34" charset="-120"/>
-              </a:rPr>
-              <a:t>First employee at AvidXchange in 2000, through its October 2021 NASDAQ IPO (AVDX), now one of the largest accounts payable automation platforms in the country. </a:t>
-            </a:r>
-            <a:pPr algn="l" indent="0" marL="0">
-              <a:lnSpc>
-                <a:spcPct val="106000"/>
-              </a:lnSpc>
-              <a:buNone/>
-            </a:pPr>
-            <a:r>
-              <a:rPr lang="en-US" sz="1250" dirty="0">
-                <a:solidFill>
-                  <a:srgbClr val="94A3B8"/>
-                </a:solidFill>
-                <a:latin typeface="Nunito" pitchFamily="34" charset="0"/>
-                <a:ea typeface="Nunito" pitchFamily="34" charset="-122"/>
-                <a:cs typeface="Nunito" pitchFamily="34" charset="-120"/>
-              </a:rPr>
-              <a:t>Also adjunct professor of entrepreneurship at UNC Charlotte and Queens University of Charlotte.</a:t>
-            </a:r>
-            <a:endParaRPr lang="en-US" sz="1250" dirty="0"/>
-          </a:p>
-        </p:txBody>
-      </p:sp>
-      <p:sp>
-        <p:nvSpPr>
-          <p:cNvPr id="21" name="Shape 15"/>
-          <p:cNvSpPr/>
-          <p:nvPr/>
-        </p:nvSpPr>
-        <p:spPr>
-          <a:xfrm>
-            <a:off x="566928" y="5257800"/>
-            <a:ext cx="11055096" cy="658368"/>
-          </a:xfrm>
-          <a:prstGeom prst="roundRect">
-            <a:avLst>
-              <a:gd name="adj" fmla="val 8333"/>
-            </a:avLst>
-          </a:prstGeom>
-          <a:solidFill>
-            <a:srgbClr val="FBBF24">
-              <a:alpha val="10000"/>
-            </a:srgbClr>
-          </a:solidFill>
-          <a:ln w="12700">
-            <a:solidFill>
-              <a:srgbClr val="FBBF24"/>
-            </a:solidFill>
-            <a:prstDash val="dash"/>
-          </a:ln>
-        </p:spPr>
-      </p:sp>
-      <p:sp>
-        <p:nvSpPr>
-          <p:cNvPr id="22" name="Shape 16"/>
-          <p:cNvSpPr/>
+          <p:cNvPr id="22" name="Text 16"/>
+          <p:cNvSpPr txBox="1"/>
           <p:nvPr/>
         </p:nvSpPr>
         <p:spPr>
@@ -3834,59 +3918,37 @@
             <a:off x="694944" y="5376672"/>
             <a:ext cx="713232" cy="237744"/>
           </a:xfrm>
-          <a:prstGeom prst="roundRect">
-            <a:avLst>
-              <a:gd name="adj" fmla="val 15385"/>
-            </a:avLst>
-          </a:prstGeom>
-          <a:solidFill>
-            <a:srgbClr val="FBBF24"/>
-          </a:solidFill>
-          <a:ln/>
-        </p:spPr>
+          <a:prstGeom prst="rect">
+            <a:avLst/>
+          </a:prstGeom>
+          <a:noFill/>
+          <a:ln/>
+        </p:spPr>
+        <p:txBody>
+          <a:bodyPr wrap="square" lIns="0" tIns="0" rIns="0" bIns="0" rtlCol="0" anchor="ctr"/>
+          <a:lstStyle/>
+          <a:p>
+            <a:pPr algn="ctr" indent="0" marL="0">
+              <a:buNone/>
+            </a:pPr>
+            <a:r>
+              <a:rPr lang="en-US" sz="1000" b="1" spc="100" kern="0" dirty="0">
+                <a:solidFill>
+                  <a:srgbClr val="3B2E00"/>
+                </a:solidFill>
+                <a:latin typeface="Nunito" pitchFamily="34" charset="0"/>
+                <a:ea typeface="Nunito" pitchFamily="34" charset="-122"/>
+                <a:cs typeface="Nunito" pitchFamily="34" charset="-120"/>
+              </a:rPr>
+              <a:t>DRAFT</a:t>
+            </a:r>
+            <a:endParaRPr lang="en-US" sz="1000" dirty="0"/>
+          </a:p>
+        </p:txBody>
       </p:sp>
       <p:sp>
         <p:nvSpPr>
           <p:cNvPr id="23" name="Text 17"/>
-          <p:cNvSpPr txBox="1"/>
-          <p:nvPr/>
-        </p:nvSpPr>
-        <p:spPr>
-          <a:xfrm>
-            <a:off x="694944" y="5376672"/>
-            <a:ext cx="713232" cy="237744"/>
-          </a:xfrm>
-          <a:prstGeom prst="rect">
-            <a:avLst/>
-          </a:prstGeom>
-          <a:noFill/>
-          <a:ln/>
-        </p:spPr>
-        <p:txBody>
-          <a:bodyPr wrap="square" lIns="0" tIns="0" rIns="0" bIns="0" rtlCol="0" anchor="ctr"/>
-          <a:lstStyle/>
-          <a:p>
-            <a:pPr algn="ctr" indent="0" marL="0">
-              <a:buNone/>
-            </a:pPr>
-            <a:r>
-              <a:rPr lang="en-US" sz="1000" b="1" spc="100" kern="0" dirty="0">
-                <a:solidFill>
-                  <a:srgbClr val="3B2E00"/>
-                </a:solidFill>
-                <a:latin typeface="Nunito" pitchFamily="34" charset="0"/>
-                <a:ea typeface="Nunito" pitchFamily="34" charset="-122"/>
-                <a:cs typeface="Nunito" pitchFamily="34" charset="-120"/>
-              </a:rPr>
-              <a:t>DRAFT</a:t>
-            </a:r>
-            <a:endParaRPr lang="en-US" sz="1000" dirty="0"/>
-          </a:p>
-        </p:txBody>
-      </p:sp>
-      <p:sp>
-        <p:nvSpPr>
-          <p:cNvPr id="24" name="Text 18"/>
           <p:cNvSpPr txBox="1"/>
           <p:nvPr/>
         </p:nvSpPr>

</xml_diff>